<commit_message>
feat: add high-res pizza photography to presentation slides and readme
</commit_message>
<xml_diff>
--- a/Dominos_SQL_Analysis_Project.pptx
+++ b/Dominos_SQL_Analysis_Project.pptx
@@ -3154,16 +3154,40 @@
           </a:p>
         </p:txBody>
       </p:sp>
-      <p:sp>
-        <p:nvSpPr>
-          <p:cNvPr id="3" name="TextBox 2"/>
+      <p:pic>
+        <p:nvPicPr>
+          <p:cNvPr id="3" name="Picture 2" descr="hero_pizza.jpg"/>
+          <p:cNvPicPr>
+            <a:picLocks noChangeAspect="1"/>
+          </p:cNvPicPr>
+          <p:nvPr/>
+        </p:nvPicPr>
+        <p:blipFill>
+          <a:blip r:embed="rId2"/>
+          <a:stretch>
+            <a:fillRect/>
+          </a:stretch>
+        </p:blipFill>
+        <p:spPr>
+          <a:xfrm>
+            <a:off x="6858000" y="731520"/>
+            <a:ext cx="4754880" cy="2926080"/>
+          </a:xfrm>
+          <a:prstGeom prst="rect">
+            <a:avLst/>
+          </a:prstGeom>
+        </p:spPr>
+      </p:pic>
+      <p:sp>
+        <p:nvSpPr>
+          <p:cNvPr id="4" name="TextBox 3"/>
           <p:cNvSpPr txBox="1"/>
           <p:nvPr/>
         </p:nvSpPr>
         <p:spPr>
           <a:xfrm>
-            <a:off x="731520" y="1097280"/>
-            <a:ext cx="6858000" cy="3200400"/>
+            <a:off x="731520" y="914400"/>
+            <a:ext cx="5943600" cy="4114800"/>
           </a:xfrm>
           <a:prstGeom prst="rect">
             <a:avLst/>
@@ -3205,7 +3229,7 @@
           </a:p>
           <a:p>
             <a:pPr>
-              <a:defRPr sz="1400">
+              <a:defRPr sz="1350">
                 <a:solidFill>
                   <a:srgbClr val="CBD5E1"/>
                 </a:solidFill>
@@ -3219,14 +3243,14 @@
       </p:sp>
       <p:sp>
         <p:nvSpPr>
-          <p:cNvPr id="4" name="Rounded Rectangle 3"/>
+          <p:cNvPr id="5" name="Rounded Rectangle 4"/>
           <p:cNvSpPr/>
           <p:nvPr/>
         </p:nvSpPr>
         <p:spPr>
           <a:xfrm>
-            <a:off x="8046720" y="1097280"/>
-            <a:ext cx="3474720" cy="1051560"/>
+            <a:off x="731520" y="4937760"/>
+            <a:ext cx="2468880" cy="1188720"/>
           </a:xfrm>
           <a:prstGeom prst="roundRect">
             <a:avLst/>
@@ -3255,7 +3279,7 @@
           </a:fontRef>
         </p:style>
         <p:txBody>
-          <a:bodyPr rtlCol="0" anchor="ctr" wrap="square" lIns="182880" tIns="91440"/>
+          <a:bodyPr rtlCol="0" anchor="ctr" wrap="square"/>
           <a:lstStyle/>
           <a:p>
             <a:pPr algn="ctr">
@@ -3266,12 +3290,12 @@
               </a:defRPr>
             </a:pPr>
             <a:r>
-              <a:t>TOTAL SALES REVENUE</a:t>
-            </a:r>
-          </a:p>
-          <a:p>
-            <a:pPr>
-              <a:defRPr sz="2000" b="1">
+              <a:t>TOTAL REVENUE</a:t>
+            </a:r>
+          </a:p>
+          <a:p>
+            <a:pPr>
+              <a:defRPr sz="2200" b="1">
                 <a:solidFill>
                   <a:srgbClr val="38BDF8"/>
                 </a:solidFill>
@@ -3281,30 +3305,18 @@
               <a:t>$817,860.05</a:t>
             </a:r>
           </a:p>
-          <a:p>
-            <a:pPr>
-              <a:defRPr sz="850">
-                <a:solidFill>
-                  <a:srgbClr val="94A3B8"/>
-                </a:solidFill>
-              </a:defRPr>
-            </a:pPr>
-            <a:r>
-              <a:t>358 operating days across 2015</a:t>
-            </a:r>
-          </a:p>
-        </p:txBody>
-      </p:sp>
-      <p:sp>
-        <p:nvSpPr>
-          <p:cNvPr id="5" name="Rounded Rectangle 4"/>
+        </p:txBody>
+      </p:sp>
+      <p:sp>
+        <p:nvSpPr>
+          <p:cNvPr id="6" name="Rounded Rectangle 5"/>
           <p:cNvSpPr/>
           <p:nvPr/>
         </p:nvSpPr>
         <p:spPr>
           <a:xfrm>
-            <a:off x="8046720" y="2331720"/>
-            <a:ext cx="3474720" cy="1051560"/>
+            <a:off x="3429000" y="4937760"/>
+            <a:ext cx="2468880" cy="1188720"/>
           </a:xfrm>
           <a:prstGeom prst="roundRect">
             <a:avLst/>
@@ -3333,7 +3345,7 @@
           </a:fontRef>
         </p:style>
         <p:txBody>
-          <a:bodyPr rtlCol="0" anchor="ctr" wrap="square" lIns="182880" tIns="91440"/>
+          <a:bodyPr rtlCol="0" anchor="ctr" wrap="square"/>
           <a:lstStyle/>
           <a:p>
             <a:pPr algn="ctr">
@@ -3344,12 +3356,12 @@
               </a:defRPr>
             </a:pPr>
             <a:r>
-              <a:t>TOTAL ORDERS PLACED</a:t>
-            </a:r>
-          </a:p>
-          <a:p>
-            <a:pPr>
-              <a:defRPr sz="2000" b="1">
+              <a:t>TOTAL ORDERS</a:t>
+            </a:r>
+          </a:p>
+          <a:p>
+            <a:pPr>
+              <a:defRPr sz="2200" b="1">
                 <a:solidFill>
                   <a:srgbClr val="FFFFFF"/>
                 </a:solidFill>
@@ -3359,30 +3371,18 @@
               <a:t>21,350</a:t>
             </a:r>
           </a:p>
-          <a:p>
-            <a:pPr>
-              <a:defRPr sz="850">
-                <a:solidFill>
-                  <a:srgbClr val="94A3B8"/>
-                </a:solidFill>
-              </a:defRPr>
-            </a:pPr>
-            <a:r>
-              <a:t>Unique customer transactions</a:t>
-            </a:r>
-          </a:p>
-        </p:txBody>
-      </p:sp>
-      <p:sp>
-        <p:nvSpPr>
-          <p:cNvPr id="6" name="Rounded Rectangle 5"/>
+        </p:txBody>
+      </p:sp>
+      <p:sp>
+        <p:nvSpPr>
+          <p:cNvPr id="7" name="Rounded Rectangle 6"/>
           <p:cNvSpPr/>
           <p:nvPr/>
         </p:nvSpPr>
         <p:spPr>
           <a:xfrm>
-            <a:off x="8046720" y="3566160"/>
-            <a:ext cx="3474720" cy="1051560"/>
+            <a:off x="6126480" y="4937760"/>
+            <a:ext cx="2468880" cy="1188720"/>
           </a:xfrm>
           <a:prstGeom prst="roundRect">
             <a:avLst/>
@@ -3411,7 +3411,7 @@
           </a:fontRef>
         </p:style>
         <p:txBody>
-          <a:bodyPr rtlCol="0" anchor="ctr" wrap="square" lIns="182880" tIns="91440"/>
+          <a:bodyPr rtlCol="0" anchor="ctr" wrap="square"/>
           <a:lstStyle/>
           <a:p>
             <a:pPr algn="ctr">
@@ -3422,12 +3422,12 @@
               </a:defRPr>
             </a:pPr>
             <a:r>
-              <a:t>TOTAL PIZZAS SOLD</a:t>
-            </a:r>
-          </a:p>
-          <a:p>
-            <a:pPr>
-              <a:defRPr sz="2000" b="1">
+              <a:t>PIZZAS SOLD</a:t>
+            </a:r>
+          </a:p>
+          <a:p>
+            <a:pPr>
+              <a:defRPr sz="2200" b="1">
                 <a:solidFill>
                   <a:srgbClr val="E31837"/>
                 </a:solidFill>
@@ -3437,30 +3437,18 @@
               <a:t>49,574</a:t>
             </a:r>
           </a:p>
-          <a:p>
-            <a:pPr>
-              <a:defRPr sz="850">
-                <a:solidFill>
-                  <a:srgbClr val="94A3B8"/>
-                </a:solidFill>
-              </a:defRPr>
-            </a:pPr>
-            <a:r>
-              <a:t>Units prepared and delivered</a:t>
-            </a:r>
-          </a:p>
-        </p:txBody>
-      </p:sp>
-      <p:sp>
-        <p:nvSpPr>
-          <p:cNvPr id="7" name="Rounded Rectangle 6"/>
+        </p:txBody>
+      </p:sp>
+      <p:sp>
+        <p:nvSpPr>
+          <p:cNvPr id="8" name="Rounded Rectangle 7"/>
           <p:cNvSpPr/>
           <p:nvPr/>
         </p:nvSpPr>
         <p:spPr>
           <a:xfrm>
-            <a:off x="8046720" y="4800600"/>
-            <a:ext cx="3474720" cy="1051560"/>
+            <a:off x="8823960" y="4937760"/>
+            <a:ext cx="2468880" cy="1188720"/>
           </a:xfrm>
           <a:prstGeom prst="roundRect">
             <a:avLst/>
@@ -3489,7 +3477,7 @@
           </a:fontRef>
         </p:style>
         <p:txBody>
-          <a:bodyPr rtlCol="0" anchor="ctr" wrap="square" lIns="182880" tIns="91440"/>
+          <a:bodyPr rtlCol="0" anchor="ctr" wrap="square"/>
           <a:lstStyle/>
           <a:p>
             <a:pPr algn="ctr">
@@ -3500,12 +3488,12 @@
               </a:defRPr>
             </a:pPr>
             <a:r>
-              <a:t>AVERAGE ORDER VALUE</a:t>
-            </a:r>
-          </a:p>
-          <a:p>
-            <a:pPr>
-              <a:defRPr sz="2000" b="1">
+              <a:t>AVG BASKET</a:t>
+            </a:r>
+          </a:p>
+          <a:p>
+            <a:pPr>
+              <a:defRPr sz="2200" b="1">
                 <a:solidFill>
                   <a:srgbClr val="34D399"/>
                 </a:solidFill>
@@ -3513,18 +3501,6 @@
             </a:pPr>
             <a:r>
               <a:t>$38.31</a:t>
-            </a:r>
-          </a:p>
-          <a:p>
-            <a:pPr>
-              <a:defRPr sz="850">
-                <a:solidFill>
-                  <a:srgbClr val="94A3B8"/>
-                </a:solidFill>
-              </a:defRPr>
-            </a:pPr>
-            <a:r>
-              <a:t>Avg basket spend (2.32 pizzas/order)</a:t>
             </a:r>
           </a:p>
         </p:txBody>
@@ -7199,16 +7175,40 @@
           </a:p>
         </p:txBody>
       </p:sp>
-      <p:sp>
-        <p:nvSpPr>
-          <p:cNvPr id="3" name="TextBox 2"/>
+      <p:pic>
+        <p:nvPicPr>
+          <p:cNvPr id="3" name="Picture 2" descr="pizza_dining.jpg"/>
+          <p:cNvPicPr>
+            <a:picLocks noChangeAspect="1"/>
+          </p:cNvPicPr>
+          <p:nvPr/>
+        </p:nvPicPr>
+        <p:blipFill>
+          <a:blip r:embed="rId2"/>
+          <a:stretch>
+            <a:fillRect/>
+          </a:stretch>
+        </p:blipFill>
+        <p:spPr>
+          <a:xfrm>
+            <a:off x="6858000" y="731520"/>
+            <a:ext cx="4754880" cy="2926080"/>
+          </a:xfrm>
+          <a:prstGeom prst="rect">
+            <a:avLst/>
+          </a:prstGeom>
+        </p:spPr>
+      </p:pic>
+      <p:sp>
+        <p:nvSpPr>
+          <p:cNvPr id="4" name="TextBox 3"/>
           <p:cNvSpPr txBox="1"/>
           <p:nvPr/>
         </p:nvSpPr>
         <p:spPr>
           <a:xfrm>
-            <a:off x="1371600" y="1097280"/>
-            <a:ext cx="9418320" cy="2011680"/>
+            <a:off x="731520" y="914400"/>
+            <a:ext cx="5943600" cy="4114800"/>
           </a:xfrm>
           <a:prstGeom prst="rect">
             <a:avLst/>
@@ -7221,7 +7221,7 @@
           </a:bodyPr>
           <a:lstStyle/>
           <a:p>
-            <a:pPr algn="ctr">
+            <a:pPr>
               <a:defRPr sz="1200" b="1">
                 <a:solidFill>
                   <a:srgbClr val="38BDF8"/>
@@ -7233,8 +7233,8 @@
             </a:r>
           </a:p>
           <a:p>
-            <a:pPr algn="ctr">
-              <a:defRPr sz="3200" b="1">
+            <a:pPr>
+              <a:defRPr sz="3000" b="1">
                 <a:solidFill>
                   <a:srgbClr val="FFFFFF"/>
                 </a:solidFill>
@@ -7249,8 +7249,8 @@
             </a:r>
           </a:p>
           <a:p>
-            <a:pPr algn="ctr">
-              <a:defRPr sz="1300">
+            <a:pPr>
+              <a:defRPr sz="1250">
                 <a:solidFill>
                   <a:srgbClr val="CBD5E1"/>
                 </a:solidFill>
@@ -7264,14 +7264,14 @@
       </p:sp>
       <p:sp>
         <p:nvSpPr>
-          <p:cNvPr id="4" name="Rounded Rectangle 3"/>
+          <p:cNvPr id="5" name="Rounded Rectangle 4"/>
           <p:cNvSpPr/>
           <p:nvPr/>
         </p:nvSpPr>
         <p:spPr>
           <a:xfrm>
-            <a:off x="1097280" y="3474720"/>
-            <a:ext cx="2286000" cy="1645920"/>
+            <a:off x="731520" y="4937760"/>
+            <a:ext cx="2468880" cy="1188720"/>
           </a:xfrm>
           <a:prstGeom prst="roundRect">
             <a:avLst/>
@@ -7304,7 +7304,7 @@
           <a:lstStyle/>
           <a:p>
             <a:pPr algn="ctr">
-              <a:defRPr sz="1300" b="1">
+              <a:defRPr sz="1100" b="1">
                 <a:solidFill>
                   <a:srgbClr val="006491"/>
                 </a:solidFill>
@@ -7316,7 +7316,7 @@
           </a:p>
           <a:p>
             <a:pPr>
-              <a:defRPr sz="1000">
+              <a:defRPr sz="900">
                 <a:solidFill>
                   <a:srgbClr val="94A3B8"/>
                 </a:solidFill>
@@ -7330,14 +7330,14 @@
       </p:sp>
       <p:sp>
         <p:nvSpPr>
-          <p:cNvPr id="5" name="Rounded Rectangle 4"/>
+          <p:cNvPr id="6" name="Rounded Rectangle 5"/>
           <p:cNvSpPr/>
           <p:nvPr/>
         </p:nvSpPr>
         <p:spPr>
           <a:xfrm>
-            <a:off x="3611880" y="3474720"/>
-            <a:ext cx="2286000" cy="1645920"/>
+            <a:off x="3429000" y="4937760"/>
+            <a:ext cx="2468880" cy="1188720"/>
           </a:xfrm>
           <a:prstGeom prst="roundRect">
             <a:avLst/>
@@ -7370,7 +7370,7 @@
           <a:lstStyle/>
           <a:p>
             <a:pPr algn="ctr">
-              <a:defRPr sz="1300" b="1">
+              <a:defRPr sz="1100" b="1">
                 <a:solidFill>
                   <a:srgbClr val="0284C7"/>
                 </a:solidFill>
@@ -7382,7 +7382,7 @@
           </a:p>
           <a:p>
             <a:pPr>
-              <a:defRPr sz="1000">
+              <a:defRPr sz="900">
                 <a:solidFill>
                   <a:srgbClr val="94A3B8"/>
                 </a:solidFill>
@@ -7396,14 +7396,14 @@
       </p:sp>
       <p:sp>
         <p:nvSpPr>
-          <p:cNvPr id="6" name="Rounded Rectangle 5"/>
+          <p:cNvPr id="7" name="Rounded Rectangle 6"/>
           <p:cNvSpPr/>
           <p:nvPr/>
         </p:nvSpPr>
         <p:spPr>
           <a:xfrm>
-            <a:off x="6126480" y="3474720"/>
-            <a:ext cx="2286000" cy="1645920"/>
+            <a:off x="6126480" y="4937760"/>
+            <a:ext cx="2468880" cy="1188720"/>
           </a:xfrm>
           <a:prstGeom prst="roundRect">
             <a:avLst/>
@@ -7436,7 +7436,7 @@
           <a:lstStyle/>
           <a:p>
             <a:pPr algn="ctr">
-              <a:defRPr sz="1300" b="1">
+              <a:defRPr sz="1100" b="1">
                 <a:solidFill>
                   <a:srgbClr val="E31837"/>
                 </a:solidFill>
@@ -7448,7 +7448,7 @@
           </a:p>
           <a:p>
             <a:pPr>
-              <a:defRPr sz="1000">
+              <a:defRPr sz="900">
                 <a:solidFill>
                   <a:srgbClr val="94A3B8"/>
                 </a:solidFill>
@@ -7462,14 +7462,14 @@
       </p:sp>
       <p:sp>
         <p:nvSpPr>
-          <p:cNvPr id="7" name="Rounded Rectangle 6"/>
+          <p:cNvPr id="8" name="Rounded Rectangle 7"/>
           <p:cNvSpPr/>
           <p:nvPr/>
         </p:nvSpPr>
         <p:spPr>
           <a:xfrm>
-            <a:off x="8641080" y="3474720"/>
-            <a:ext cx="2286000" cy="1645920"/>
+            <a:off x="8823960" y="4937760"/>
+            <a:ext cx="2468880" cy="1188720"/>
           </a:xfrm>
           <a:prstGeom prst="roundRect">
             <a:avLst/>
@@ -7502,7 +7502,7 @@
           <a:lstStyle/>
           <a:p>
             <a:pPr algn="ctr">
-              <a:defRPr sz="1300" b="1">
+              <a:defRPr sz="1100" b="1">
                 <a:solidFill>
                   <a:srgbClr val="10B981"/>
                 </a:solidFill>
@@ -7514,7 +7514,7 @@
           </a:p>
           <a:p>
             <a:pPr>
-              <a:defRPr sz="1000">
+              <a:defRPr sz="900">
                 <a:solidFill>
                   <a:srgbClr val="94A3B8"/>
                 </a:solidFill>
@@ -7522,60 +7522,6 @@
             </a:pPr>
             <a:r>
               <a:t>Inventory buffers, shift rosters, menu pruning</a:t>
-            </a:r>
-          </a:p>
-        </p:txBody>
-      </p:sp>
-      <p:sp>
-        <p:nvSpPr>
-          <p:cNvPr id="8" name="Rounded Rectangle 7"/>
-          <p:cNvSpPr/>
-          <p:nvPr/>
-        </p:nvSpPr>
-        <p:spPr>
-          <a:xfrm>
-            <a:off x="2743200" y="5486400"/>
-            <a:ext cx="6702552" cy="731520"/>
-          </a:xfrm>
-          <a:prstGeom prst="roundRect">
-            <a:avLst/>
-          </a:prstGeom>
-          <a:solidFill>
-            <a:srgbClr val="006491"/>
-          </a:solidFill>
-          <a:ln w="12700">
-            <a:solidFill>
-              <a:srgbClr val="38BDF8"/>
-            </a:solidFill>
-          </a:ln>
-        </p:spPr>
-        <p:style>
-          <a:lnRef idx="1">
-            <a:schemeClr val="accent1"/>
-          </a:lnRef>
-          <a:fillRef idx="3">
-            <a:schemeClr val="accent1"/>
-          </a:fillRef>
-          <a:effectRef idx="2">
-            <a:schemeClr val="accent1"/>
-          </a:effectRef>
-          <a:fontRef idx="minor">
-            <a:schemeClr val="lt1"/>
-          </a:fontRef>
-        </p:style>
-        <p:txBody>
-          <a:bodyPr rtlCol="0" anchor="ctr" wrap="square"/>
-          <a:lstStyle/>
-          <a:p>
-            <a:pPr algn="ctr">
-              <a:defRPr sz="1300" b="1">
-                <a:solidFill>
-                  <a:srgbClr val="FFFFFF"/>
-                </a:solidFill>
-              </a:defRPr>
-            </a:pPr>
-            <a:r>
-              <a:t>💼 Portfolio Showcase  |  GitHub Ready  |  Interview Presentation Deck</a:t>
             </a:r>
           </a:p>
         </p:txBody>
@@ -7942,98 +7888,147 @@
           </a:fontRef>
         </p:style>
         <p:txBody>
-          <a:bodyPr rtlCol="0" anchor="ctr" wrap="square"/>
-          <a:lstStyle/>
-          <a:p>
-            <a:pPr algn="ctr">
-              <a:defRPr b="1" sz="1300">
+          <a:bodyPr rtlCol="0" anchor="ctr"/>
+          <a:lstStyle/>
+          <a:p>
+            <a:pPr algn="ctr"/>
+          </a:p>
+        </p:txBody>
+      </p:sp>
+      <p:pic>
+        <p:nvPicPr>
+          <p:cNvPr id="9" name="Picture 8" descr="pizza_cutting.jpg"/>
+          <p:cNvPicPr>
+            <a:picLocks noChangeAspect="1"/>
+          </p:cNvPicPr>
+          <p:nvPr/>
+        </p:nvPicPr>
+        <p:blipFill>
+          <a:blip r:embed="rId2"/>
+          <a:stretch>
+            <a:fillRect/>
+          </a:stretch>
+        </p:blipFill>
+        <p:spPr>
+          <a:xfrm>
+            <a:off x="6400800" y="1737360"/>
+            <a:ext cx="2011680" cy="2011680"/>
+          </a:xfrm>
+          <a:prstGeom prst="rect">
+            <a:avLst/>
+          </a:prstGeom>
+        </p:spPr>
+      </p:pic>
+      <p:sp>
+        <p:nvSpPr>
+          <p:cNvPr id="10" name="TextBox 9"/>
+          <p:cNvSpPr txBox="1"/>
+          <p:nvPr/>
+        </p:nvSpPr>
+        <p:spPr>
+          <a:xfrm>
+            <a:off x="8595360" y="1645920"/>
+            <a:ext cx="2834640" cy="3291840"/>
+          </a:xfrm>
+          <a:prstGeom prst="rect">
+            <a:avLst/>
+          </a:prstGeom>
+          <a:noFill/>
+        </p:spPr>
+        <p:txBody>
+          <a:bodyPr wrap="square">
+            <a:spAutoFit/>
+          </a:bodyPr>
+          <a:lstStyle/>
+          <a:p>
+            <a:pPr>
+              <a:defRPr sz="1100" b="1">
                 <a:solidFill>
                   <a:srgbClr val="0B2341"/>
                 </a:solidFill>
               </a:defRPr>
             </a:pPr>
             <a:r>
-              <a:t>DATASET SCOPE &amp; ANALYTICAL RIGOR</a:t>
-            </a:r>
-            <a:br/>
-          </a:p>
-          <a:p>
-            <a:pPr>
-              <a:defRPr sz="1050">
+              <a:t>OPERATIONAL SCOPE</a:t>
+            </a:r>
+          </a:p>
+          <a:p>
+            <a:pPr>
+              <a:defRPr sz="1000">
                 <a:solidFill>
                   <a:srgbClr val="006491"/>
                 </a:solidFill>
               </a:defRPr>
             </a:pPr>
             <a:r>
-              <a:t>✔ Database Engine: MySQL 8.0 Relational Database</a:t>
-            </a:r>
-          </a:p>
-          <a:p>
-            <a:pPr>
-              <a:defRPr sz="1050">
+              <a:t>✔ Engine: MySQL 8.0</a:t>
+            </a:r>
+          </a:p>
+          <a:p>
+            <a:pPr>
+              <a:defRPr sz="1000">
                 <a:solidFill>
                   <a:srgbClr val="006491"/>
                 </a:solidFill>
               </a:defRPr>
             </a:pPr>
             <a:r>
-              <a:t>✔ Temporal Bounds: 358 Operating Days (2015-01-01 to 2015-12-31)</a:t>
-            </a:r>
-          </a:p>
-          <a:p>
-            <a:pPr>
-              <a:defRPr sz="1050">
+              <a:t>✔ Scope: 358 Operating Days</a:t>
+            </a:r>
+          </a:p>
+          <a:p>
+            <a:pPr>
+              <a:defRPr sz="1000">
                 <a:solidFill>
                   <a:srgbClr val="006491"/>
                 </a:solidFill>
               </a:defRPr>
             </a:pPr>
             <a:r>
-              <a:t>✔ Transaction Depth: 48,620 Order Detail Lines across 21,350 Orders</a:t>
-            </a:r>
-          </a:p>
-          <a:p>
-            <a:pPr>
-              <a:defRPr sz="1050">
+              <a:t>✔ Lines: 48,620 Order Items</a:t>
+            </a:r>
+          </a:p>
+          <a:p>
+            <a:pPr>
+              <a:defRPr sz="1000">
                 <a:solidFill>
                   <a:srgbClr val="006491"/>
                 </a:solidFill>
               </a:defRPr>
             </a:pPr>
             <a:r>
-              <a:t>✔ Product Variety: 32 Distinct Flavor Concepts across 96 Size/Price Variants</a:t>
-            </a:r>
-          </a:p>
-          <a:p>
-            <a:pPr>
-              <a:defRPr sz="1050">
+              <a:t>✔ Orders: 21,350 Transactions</a:t>
+            </a:r>
+          </a:p>
+          <a:p>
+            <a:pPr>
+              <a:defRPr sz="1000">
                 <a:solidFill>
                   <a:srgbClr val="006491"/>
                 </a:solidFill>
               </a:defRPr>
             </a:pPr>
             <a:r>
-              <a:t>✔ Data Integrity: 100% Referential integrity, 0 orphaned records across FKs</a:t>
-            </a:r>
-          </a:p>
-          <a:p>
-            <a:pPr>
-              <a:defRPr sz="1050">
+              <a:t>✔ Menu: 32 Pizzas / 96 SKUs</a:t>
+            </a:r>
+          </a:p>
+          <a:p>
+            <a:pPr>
+              <a:defRPr sz="1000">
                 <a:solidFill>
                   <a:srgbClr val="006491"/>
                 </a:solidFill>
               </a:defRPr>
             </a:pPr>
             <a:r>
-              <a:t>✔ Fidelity Guarantee: All reported metrics are verified against actual query results.</a:t>
-            </a:r>
-          </a:p>
-        </p:txBody>
-      </p:sp>
-      <p:sp>
-        <p:nvSpPr>
-          <p:cNvPr id="9" name="Rounded Rectangle 8"/>
+              <a:t>✔ Zero orphaned records</a:t>
+            </a:r>
+          </a:p>
+        </p:txBody>
+      </p:sp>
+      <p:sp>
+        <p:nvSpPr>
+          <p:cNvPr id="11" name="Rounded Rectangle 10"/>
           <p:cNvSpPr/>
           <p:nvPr/>
         </p:nvSpPr>
@@ -8099,7 +8094,7 @@
       </p:sp>
       <p:sp>
         <p:nvSpPr>
-          <p:cNvPr id="10" name="Rounded Rectangle 9"/>
+          <p:cNvPr id="12" name="Rounded Rectangle 11"/>
           <p:cNvSpPr/>
           <p:nvPr/>
         </p:nvSpPr>
@@ -9543,18 +9538,6 @@
               <a:t>21,350</a:t>
             </a:r>
           </a:p>
-          <a:p>
-            <a:pPr>
-              <a:defRPr sz="900">
-                <a:solidFill>
-                  <a:srgbClr val="64748B"/>
-                </a:solidFill>
-              </a:defRPr>
-            </a:pPr>
-            <a:r>
-              <a:t>Total customer orders processed in 2015</a:t>
-            </a:r>
-          </a:p>
         </p:txBody>
       </p:sp>
       <p:sp>
@@ -9621,18 +9604,6 @@
               <a:t>$817,860.05</a:t>
             </a:r>
           </a:p>
-          <a:p>
-            <a:pPr>
-              <a:defRPr sz="900">
-                <a:solidFill>
-                  <a:srgbClr val="64748B"/>
-                </a:solidFill>
-              </a:defRPr>
-            </a:pPr>
-            <a:r>
-              <a:t>Gross sales across 49,574 pizzas</a:t>
-            </a:r>
-          </a:p>
         </p:txBody>
       </p:sp>
       <p:sp>
@@ -9699,18 +9670,6 @@
               <a:t>$38.31</a:t>
             </a:r>
           </a:p>
-          <a:p>
-            <a:pPr>
-              <a:defRPr sz="900">
-                <a:solidFill>
-                  <a:srgbClr val="64748B"/>
-                </a:solidFill>
-              </a:defRPr>
-            </a:pPr>
-            <a:r>
-              <a:t>Revenue / Total Orders ($817.8K / 21.35K)</a:t>
-            </a:r>
-          </a:p>
         </p:txBody>
       </p:sp>
       <p:sp>
@@ -9775,18 +9734,6 @@
             </a:pPr>
             <a:r>
               <a:t>49,574</a:t>
-            </a:r>
-          </a:p>
-          <a:p>
-            <a:pPr>
-              <a:defRPr sz="900">
-                <a:solidFill>
-                  <a:srgbClr val="64748B"/>
-                </a:solidFill>
-              </a:defRPr>
-            </a:pPr>
-            <a:r>
-              <a:t>Avg 2.32 pizzas per customer order</a:t>
             </a:r>
           </a:p>
         </p:txBody>
@@ -10141,7 +10088,7 @@
         <p:spPr>
           <a:xfrm>
             <a:off x="548640" y="1554480"/>
-            <a:ext cx="5303520" cy="2011680"/>
+            <a:ext cx="5303520" cy="1920240"/>
           </a:xfrm>
           <a:prstGeom prst="roundRect">
             <a:avLst/>
@@ -10335,8 +10282,8 @@
         </p:nvSpPr>
         <p:spPr>
           <a:xfrm>
-            <a:off x="548640" y="3703320"/>
-            <a:ext cx="5303520" cy="1508760"/>
+            <a:off x="548640" y="3611880"/>
+            <a:ext cx="5303520" cy="1691640"/>
           </a:xfrm>
           <a:prstGeom prst="roundRect">
             <a:avLst/>
@@ -10365,49 +10312,16 @@
           </a:fontRef>
         </p:style>
         <p:txBody>
-          <a:bodyPr rtlCol="0" anchor="ctr" wrap="square"/>
-          <a:lstStyle/>
-          <a:p>
-            <a:pPr algn="ctr">
-              <a:defRPr sz="1000" b="1">
-                <a:solidFill>
-                  <a:srgbClr val="64748B"/>
-                </a:solidFill>
-              </a:defRPr>
-            </a:pPr>
-            <a:r>
-              <a:t>QUERY 3 RESULT: HIGHEST-PRICED MENU ITEM</a:t>
-            </a:r>
-          </a:p>
-          <a:p>
-            <a:pPr>
-              <a:defRPr sz="1600" b="1">
-                <a:solidFill>
-                  <a:srgbClr val="E31837"/>
-                </a:solidFill>
-              </a:defRPr>
-            </a:pPr>
-            <a:r>
-              <a:t>The Greek Pizza (XXL) — $35.95</a:t>
-            </a:r>
-          </a:p>
-          <a:p>
-            <a:pPr>
-              <a:defRPr sz="950">
-                <a:solidFill>
-                  <a:srgbClr val="1E293B"/>
-                </a:solidFill>
-              </a:defRPr>
-            </a:pPr>
-            <a:r>
-              <a:t>Only 28 XXL orders placed in entire year (0.06% of sales). Premium price does not equal volume.</a:t>
-            </a:r>
+          <a:bodyPr rtlCol="0" anchor="ctr"/>
+          <a:lstStyle/>
+          <a:p>
+            <a:pPr algn="ctr"/>
           </a:p>
         </p:txBody>
       </p:sp>
       <p:pic>
         <p:nvPicPr>
-          <p:cNvPr id="9" name="Picture 8" descr="q4_size_distribution.png"/>
+          <p:cNvPr id="9" name="Picture 8" descr="greek_pizza.jpg"/>
           <p:cNvPicPr>
             <a:picLocks noChangeAspect="1"/>
           </p:cNvPicPr>
@@ -10421,6 +10335,89 @@
         </p:blipFill>
         <p:spPr>
           <a:xfrm>
+            <a:off x="731520" y="3749039"/>
+            <a:ext cx="1280160" cy="1280160"/>
+          </a:xfrm>
+          <a:prstGeom prst="rect">
+            <a:avLst/>
+          </a:prstGeom>
+        </p:spPr>
+      </p:pic>
+      <p:sp>
+        <p:nvSpPr>
+          <p:cNvPr id="10" name="TextBox 9"/>
+          <p:cNvSpPr txBox="1"/>
+          <p:nvPr/>
+        </p:nvSpPr>
+        <p:spPr>
+          <a:xfrm>
+            <a:off x="2194560" y="3657600"/>
+            <a:ext cx="3474720" cy="1554480"/>
+          </a:xfrm>
+          <a:prstGeom prst="rect">
+            <a:avLst/>
+          </a:prstGeom>
+          <a:noFill/>
+        </p:spPr>
+        <p:txBody>
+          <a:bodyPr wrap="square">
+            <a:spAutoFit/>
+          </a:bodyPr>
+          <a:lstStyle/>
+          <a:p>
+            <a:pPr>
+              <a:defRPr sz="1000" b="1">
+                <a:solidFill>
+                  <a:srgbClr val="64748B"/>
+                </a:solidFill>
+              </a:defRPr>
+            </a:pPr>
+            <a:r>
+              <a:t>HIGHEST PRICED PIZZA (Q3)</a:t>
+            </a:r>
+          </a:p>
+          <a:p>
+            <a:pPr>
+              <a:defRPr sz="1350" b="1">
+                <a:solidFill>
+                  <a:srgbClr val="E31837"/>
+                </a:solidFill>
+              </a:defRPr>
+            </a:pPr>
+            <a:r>
+              <a:t>The Greek Pizza (XXL) — $35.95</a:t>
+            </a:r>
+          </a:p>
+          <a:p>
+            <a:pPr>
+              <a:defRPr sz="900">
+                <a:solidFill>
+                  <a:srgbClr val="64748B"/>
+                </a:solidFill>
+              </a:defRPr>
+            </a:pPr>
+            <a:r>
+              <a:t>Only 28 XXL orders placed all year (0.06% of volume). High price does not drive sales.</a:t>
+            </a:r>
+          </a:p>
+        </p:txBody>
+      </p:sp>
+      <p:pic>
+        <p:nvPicPr>
+          <p:cNvPr id="11" name="Picture 10" descr="q4_size_distribution.png"/>
+          <p:cNvPicPr>
+            <a:picLocks noChangeAspect="1"/>
+          </p:cNvPicPr>
+          <p:nvPr/>
+        </p:nvPicPr>
+        <p:blipFill>
+          <a:blip r:embed="rId3"/>
+          <a:stretch>
+            <a:fillRect/>
+          </a:stretch>
+        </p:blipFill>
+        <p:spPr>
+          <a:xfrm>
             <a:off x="6217920" y="1554480"/>
             <a:ext cx="5394960" cy="3657600"/>
           </a:xfrm>
@@ -10431,7 +10428,7 @@
       </p:pic>
       <p:sp>
         <p:nvSpPr>
-          <p:cNvPr id="10" name="Rounded Rectangle 9"/>
+          <p:cNvPr id="12" name="Rounded Rectangle 11"/>
           <p:cNvSpPr/>
           <p:nvPr/>
         </p:nvSpPr>
@@ -10497,7 +10494,7 @@
       </p:sp>
       <p:sp>
         <p:nvSpPr>
-          <p:cNvPr id="11" name="Rounded Rectangle 10"/>
+          <p:cNvPr id="13" name="Rounded Rectangle 12"/>
           <p:cNvSpPr/>
           <p:nvPr/>
         </p:nvSpPr>
@@ -10779,7 +10776,7 @@
         <p:spPr>
           <a:xfrm>
             <a:off x="548640" y="1554480"/>
-            <a:ext cx="5303520" cy="3657600"/>
+            <a:ext cx="5303520" cy="2103120"/>
           </a:xfrm>
           <a:prstGeom prst="roundRect">
             <a:avLst/>
@@ -10944,7 +10941,7 @@
       </p:sp>
       <p:pic>
         <p:nvPicPr>
-          <p:cNvPr id="8" name="Picture 7" descr="q5_top5_pizzas.png"/>
+          <p:cNvPr id="8" name="Picture 7" descr="pepperoni_pizza.jpg"/>
           <p:cNvPicPr>
             <a:picLocks noChangeAspect="1"/>
           </p:cNvPicPr>
@@ -10958,6 +10955,226 @@
         </p:blipFill>
         <p:spPr>
           <a:xfrm>
+            <a:off x="731520" y="3840480"/>
+            <a:ext cx="1097280" cy="1097280"/>
+          </a:xfrm>
+          <a:prstGeom prst="rect">
+            <a:avLst/>
+          </a:prstGeom>
+        </p:spPr>
+      </p:pic>
+      <p:sp>
+        <p:nvSpPr>
+          <p:cNvPr id="9" name="TextBox 8"/>
+          <p:cNvSpPr txBox="1"/>
+          <p:nvPr/>
+        </p:nvSpPr>
+        <p:spPr>
+          <a:xfrm>
+            <a:off x="731520" y="4937760"/>
+            <a:ext cx="1097280" cy="274320"/>
+          </a:xfrm>
+          <a:prstGeom prst="rect">
+            <a:avLst/>
+          </a:prstGeom>
+          <a:noFill/>
+        </p:spPr>
+        <p:txBody>
+          <a:bodyPr wrap="none">
+            <a:spAutoFit/>
+          </a:bodyPr>
+          <a:lstStyle/>
+          <a:p>
+            <a:pPr algn="ctr">
+              <a:defRPr sz="850" b="1"/>
+            </a:pPr>
+            <a:r>
+              <a:t>Pepperoni</a:t>
+            </a:r>
+          </a:p>
+        </p:txBody>
+      </p:sp>
+      <p:pic>
+        <p:nvPicPr>
+          <p:cNvPr id="10" name="Picture 9" descr="bbq_chicken.jpg"/>
+          <p:cNvPicPr>
+            <a:picLocks noChangeAspect="1"/>
+          </p:cNvPicPr>
+          <p:nvPr/>
+        </p:nvPicPr>
+        <p:blipFill>
+          <a:blip r:embed="rId3"/>
+          <a:stretch>
+            <a:fillRect/>
+          </a:stretch>
+        </p:blipFill>
+        <p:spPr>
+          <a:xfrm>
+            <a:off x="1965960" y="3840480"/>
+            <a:ext cx="1097280" cy="1097280"/>
+          </a:xfrm>
+          <a:prstGeom prst="rect">
+            <a:avLst/>
+          </a:prstGeom>
+        </p:spPr>
+      </p:pic>
+      <p:sp>
+        <p:nvSpPr>
+          <p:cNvPr id="11" name="TextBox 10"/>
+          <p:cNvSpPr txBox="1"/>
+          <p:nvPr/>
+        </p:nvSpPr>
+        <p:spPr>
+          <a:xfrm>
+            <a:off x="1965960" y="4937760"/>
+            <a:ext cx="1097280" cy="274320"/>
+          </a:xfrm>
+          <a:prstGeom prst="rect">
+            <a:avLst/>
+          </a:prstGeom>
+          <a:noFill/>
+        </p:spPr>
+        <p:txBody>
+          <a:bodyPr wrap="none">
+            <a:spAutoFit/>
+          </a:bodyPr>
+          <a:lstStyle/>
+          <a:p>
+            <a:pPr algn="ctr">
+              <a:defRPr sz="850" b="1"/>
+            </a:pPr>
+            <a:r>
+              <a:t>BBQ Chicken</a:t>
+            </a:r>
+          </a:p>
+        </p:txBody>
+      </p:sp>
+      <p:pic>
+        <p:nvPicPr>
+          <p:cNvPr id="12" name="Picture 11" descr="hawaiian_pizza.jpg"/>
+          <p:cNvPicPr>
+            <a:picLocks noChangeAspect="1"/>
+          </p:cNvPicPr>
+          <p:nvPr/>
+        </p:nvPicPr>
+        <p:blipFill>
+          <a:blip r:embed="rId4"/>
+          <a:stretch>
+            <a:fillRect/>
+          </a:stretch>
+        </p:blipFill>
+        <p:spPr>
+          <a:xfrm>
+            <a:off x="3200400" y="3840480"/>
+            <a:ext cx="1097280" cy="1097280"/>
+          </a:xfrm>
+          <a:prstGeom prst="rect">
+            <a:avLst/>
+          </a:prstGeom>
+        </p:spPr>
+      </p:pic>
+      <p:sp>
+        <p:nvSpPr>
+          <p:cNvPr id="13" name="TextBox 12"/>
+          <p:cNvSpPr txBox="1"/>
+          <p:nvPr/>
+        </p:nvSpPr>
+        <p:spPr>
+          <a:xfrm>
+            <a:off x="3200400" y="4937760"/>
+            <a:ext cx="1097280" cy="274320"/>
+          </a:xfrm>
+          <a:prstGeom prst="rect">
+            <a:avLst/>
+          </a:prstGeom>
+          <a:noFill/>
+        </p:spPr>
+        <p:txBody>
+          <a:bodyPr wrap="none">
+            <a:spAutoFit/>
+          </a:bodyPr>
+          <a:lstStyle/>
+          <a:p>
+            <a:pPr algn="ctr">
+              <a:defRPr sz="850" b="1"/>
+            </a:pPr>
+            <a:r>
+              <a:t>Hawaiian</a:t>
+            </a:r>
+          </a:p>
+        </p:txBody>
+      </p:sp>
+      <p:pic>
+        <p:nvPicPr>
+          <p:cNvPr id="14" name="Picture 13" descr="thai_chicken.jpg"/>
+          <p:cNvPicPr>
+            <a:picLocks noChangeAspect="1"/>
+          </p:cNvPicPr>
+          <p:nvPr/>
+        </p:nvPicPr>
+        <p:blipFill>
+          <a:blip r:embed="rId5"/>
+          <a:stretch>
+            <a:fillRect/>
+          </a:stretch>
+        </p:blipFill>
+        <p:spPr>
+          <a:xfrm>
+            <a:off x="4434840" y="3840480"/>
+            <a:ext cx="1097280" cy="1097280"/>
+          </a:xfrm>
+          <a:prstGeom prst="rect">
+            <a:avLst/>
+          </a:prstGeom>
+        </p:spPr>
+      </p:pic>
+      <p:sp>
+        <p:nvSpPr>
+          <p:cNvPr id="15" name="TextBox 14"/>
+          <p:cNvSpPr txBox="1"/>
+          <p:nvPr/>
+        </p:nvSpPr>
+        <p:spPr>
+          <a:xfrm>
+            <a:off x="4434840" y="4937760"/>
+            <a:ext cx="1097280" cy="274320"/>
+          </a:xfrm>
+          <a:prstGeom prst="rect">
+            <a:avLst/>
+          </a:prstGeom>
+          <a:noFill/>
+        </p:spPr>
+        <p:txBody>
+          <a:bodyPr wrap="none">
+            <a:spAutoFit/>
+          </a:bodyPr>
+          <a:lstStyle/>
+          <a:p>
+            <a:pPr algn="ctr">
+              <a:defRPr sz="850" b="1"/>
+            </a:pPr>
+            <a:r>
+              <a:t>Thai Chicken</a:t>
+            </a:r>
+          </a:p>
+        </p:txBody>
+      </p:sp>
+      <p:pic>
+        <p:nvPicPr>
+          <p:cNvPr id="16" name="Picture 15" descr="q5_top5_pizzas.png"/>
+          <p:cNvPicPr>
+            <a:picLocks noChangeAspect="1"/>
+          </p:cNvPicPr>
+          <p:nvPr/>
+        </p:nvPicPr>
+        <p:blipFill>
+          <a:blip r:embed="rId6"/>
+          <a:stretch>
+            <a:fillRect/>
+          </a:stretch>
+        </p:blipFill>
+        <p:spPr>
+          <a:xfrm>
             <a:off x="6217920" y="1554480"/>
             <a:ext cx="5394960" cy="3657600"/>
           </a:xfrm>
@@ -10968,7 +11185,7 @@
       </p:pic>
       <p:sp>
         <p:nvSpPr>
-          <p:cNvPr id="9" name="Rounded Rectangle 8"/>
+          <p:cNvPr id="17" name="Rounded Rectangle 16"/>
           <p:cNvSpPr/>
           <p:nvPr/>
         </p:nvSpPr>
@@ -11034,7 +11251,7 @@
       </p:sp>
       <p:sp>
         <p:nvSpPr>
-          <p:cNvPr id="10" name="Rounded Rectangle 9"/>
+          <p:cNvPr id="18" name="Rounded Rectangle 17"/>
           <p:cNvSpPr/>
           <p:nvPr/>
         </p:nvSpPr>
@@ -11801,7 +12018,7 @@
         <p:spPr>
           <a:xfrm>
             <a:off x="548640" y="1554480"/>
-            <a:ext cx="5303520" cy="3657600"/>
+            <a:ext cx="5303520" cy="2011680"/>
           </a:xfrm>
           <a:prstGeom prst="roundRect">
             <a:avLst/>
@@ -11964,9 +12181,54 @@
           </a:p>
         </p:txBody>
       </p:sp>
+      <p:sp>
+        <p:nvSpPr>
+          <p:cNvPr id="8" name="Rounded Rectangle 7"/>
+          <p:cNvSpPr/>
+          <p:nvPr/>
+        </p:nvSpPr>
+        <p:spPr>
+          <a:xfrm>
+            <a:off x="548640" y="3703320"/>
+            <a:ext cx="5303520" cy="1600200"/>
+          </a:xfrm>
+          <a:prstGeom prst="roundRect">
+            <a:avLst/>
+          </a:prstGeom>
+          <a:solidFill>
+            <a:srgbClr val="FFFFFF"/>
+          </a:solidFill>
+          <a:ln w="12700">
+            <a:solidFill>
+              <a:srgbClr val="E2E8F0"/>
+            </a:solidFill>
+          </a:ln>
+        </p:spPr>
+        <p:style>
+          <a:lnRef idx="1">
+            <a:schemeClr val="accent1"/>
+          </a:lnRef>
+          <a:fillRef idx="3">
+            <a:schemeClr val="accent1"/>
+          </a:fillRef>
+          <a:effectRef idx="2">
+            <a:schemeClr val="accent1"/>
+          </a:effectRef>
+          <a:fontRef idx="minor">
+            <a:schemeClr val="lt1"/>
+          </a:fontRef>
+        </p:style>
+        <p:txBody>
+          <a:bodyPr rtlCol="0" anchor="ctr"/>
+          <a:lstStyle/>
+          <a:p>
+            <a:pPr algn="ctr"/>
+          </a:p>
+        </p:txBody>
+      </p:sp>
       <p:pic>
         <p:nvPicPr>
-          <p:cNvPr id="8" name="Picture 7" descr="q7_top3_revenue_pizzas.png"/>
+          <p:cNvPr id="9" name="Picture 8" descr="thai_chicken.jpg"/>
           <p:cNvPicPr>
             <a:picLocks noChangeAspect="1"/>
           </p:cNvPicPr>
@@ -11980,6 +12242,101 @@
         </p:blipFill>
         <p:spPr>
           <a:xfrm>
+            <a:off x="731520" y="3840480"/>
+            <a:ext cx="1188720" cy="1188720"/>
+          </a:xfrm>
+          <a:prstGeom prst="rect">
+            <a:avLst/>
+          </a:prstGeom>
+        </p:spPr>
+      </p:pic>
+      <p:pic>
+        <p:nvPicPr>
+          <p:cNvPr id="10" name="Picture 9" descr="bbq_chicken.jpg"/>
+          <p:cNvPicPr>
+            <a:picLocks noChangeAspect="1"/>
+          </p:cNvPicPr>
+          <p:nvPr/>
+        </p:nvPicPr>
+        <p:blipFill>
+          <a:blip r:embed="rId3"/>
+          <a:stretch>
+            <a:fillRect/>
+          </a:stretch>
+        </p:blipFill>
+        <p:spPr>
+          <a:xfrm>
+            <a:off x="2103120" y="3840480"/>
+            <a:ext cx="1188720" cy="1188720"/>
+          </a:xfrm>
+          <a:prstGeom prst="rect">
+            <a:avLst/>
+          </a:prstGeom>
+        </p:spPr>
+      </p:pic>
+      <p:sp>
+        <p:nvSpPr>
+          <p:cNvPr id="11" name="TextBox 10"/>
+          <p:cNvSpPr txBox="1"/>
+          <p:nvPr/>
+        </p:nvSpPr>
+        <p:spPr>
+          <a:xfrm>
+            <a:off x="3474720" y="3749039"/>
+            <a:ext cx="2286000" cy="1463040"/>
+          </a:xfrm>
+          <a:prstGeom prst="rect">
+            <a:avLst/>
+          </a:prstGeom>
+          <a:noFill/>
+        </p:spPr>
+        <p:txBody>
+          <a:bodyPr wrap="square">
+            <a:spAutoFit/>
+          </a:bodyPr>
+          <a:lstStyle/>
+          <a:p>
+            <a:pPr>
+              <a:defRPr sz="1000" b="1">
+                <a:solidFill>
+                  <a:srgbClr val="E31837"/>
+                </a:solidFill>
+              </a:defRPr>
+            </a:pPr>
+            <a:r>
+              <a:t>CHICKEN PREMIUM EFFECT</a:t>
+            </a:r>
+          </a:p>
+          <a:p>
+            <a:pPr>
+              <a:defRPr sz="950">
+                <a:solidFill>
+                  <a:srgbClr val="1E293B"/>
+                </a:solidFill>
+              </a:defRPr>
+            </a:pPr>
+            <a:r>
+              <a:t>All top 3 revenue leaders are Chicken pizzas ($127.6K total, 15.6% of sales).</a:t>
+            </a:r>
+          </a:p>
+        </p:txBody>
+      </p:sp>
+      <p:pic>
+        <p:nvPicPr>
+          <p:cNvPr id="12" name="Picture 11" descr="q7_top3_revenue_pizzas.png"/>
+          <p:cNvPicPr>
+            <a:picLocks noChangeAspect="1"/>
+          </p:cNvPicPr>
+          <p:nvPr/>
+        </p:nvPicPr>
+        <p:blipFill>
+          <a:blip r:embed="rId4"/>
+          <a:stretch>
+            <a:fillRect/>
+          </a:stretch>
+        </p:blipFill>
+        <p:spPr>
+          <a:xfrm>
             <a:off x="6217920" y="1554480"/>
             <a:ext cx="5394960" cy="3657600"/>
           </a:xfrm>
@@ -11990,7 +12347,7 @@
       </p:pic>
       <p:sp>
         <p:nvSpPr>
-          <p:cNvPr id="9" name="Rounded Rectangle 8"/>
+          <p:cNvPr id="13" name="Rounded Rectangle 12"/>
           <p:cNvSpPr/>
           <p:nvPr/>
         </p:nvSpPr>
@@ -12056,7 +12413,7 @@
       </p:sp>
       <p:sp>
         <p:nvSpPr>
-          <p:cNvPr id="10" name="Rounded Rectangle 9"/>
+          <p:cNvPr id="14" name="Rounded Rectangle 13"/>
           <p:cNvSpPr/>
           <p:nvPr/>
         </p:nvSpPr>

</xml_diff>